<commit_message>
powerpoint done outside final run and results, and besides script
</commit_message>
<xml_diff>
--- a/HI2459_finalproject-option1-presentation_jeb382.pptx
+++ b/HI2459_finalproject-option1-presentation_jeb382.pptx
@@ -2,19 +2,17 @@
 <file path=ppt/presentation.xml><?xml version="1.0" encoding="utf-8"?>
 <p:presentation xmlns:a="http://schemas.openxmlformats.org/drawingml/2006/main" xmlns:r="http://schemas.openxmlformats.org/officeDocument/2006/relationships" xmlns:p="http://schemas.openxmlformats.org/presentationml/2006/main" saveSubsetFonts="1">
   <p:sldMasterIdLst>
-    <p:sldMasterId id="2147483648" r:id="rId1"/>
+    <p:sldMasterId id="2147483689" r:id="rId1"/>
   </p:sldMasterIdLst>
   <p:sldIdLst>
     <p:sldId id="256" r:id="rId2"/>
     <p:sldId id="257" r:id="rId3"/>
     <p:sldId id="258" r:id="rId4"/>
     <p:sldId id="259" r:id="rId5"/>
-    <p:sldId id="260" r:id="rId6"/>
-    <p:sldId id="261" r:id="rId7"/>
-    <p:sldId id="262" r:id="rId8"/>
-    <p:sldId id="263" r:id="rId9"/>
-    <p:sldId id="264" r:id="rId10"/>
-    <p:sldId id="265" r:id="rId11"/>
+    <p:sldId id="261" r:id="rId6"/>
+    <p:sldId id="266" r:id="rId7"/>
+    <p:sldId id="264" r:id="rId8"/>
+    <p:sldId id="265" r:id="rId9"/>
   </p:sldIdLst>
   <p:sldSz cx="12192000" cy="6858000"/>
   <p:notesSz cx="6858000" cy="9144000"/>
@@ -138,7 +136,7 @@
           <p:cNvPr id="2" name="Title 1">
             <a:extLst>
               <a:ext uri="{FF2B5EF4-FFF2-40B4-BE49-F238E27FC236}">
-                <a16:creationId xmlns:a16="http://schemas.microsoft.com/office/drawing/2014/main" id="{61AC1C0E-04A5-571D-46BE-D796F8421EFD}"/>
+                <a16:creationId xmlns:a16="http://schemas.microsoft.com/office/drawing/2014/main" id="{40F21D90-DCCC-BAA8-2D91-1E27B9A35AC7}"/>
               </a:ext>
             </a:extLst>
           </p:cNvPr>
@@ -175,7 +173,7 @@
           <p:cNvPr id="3" name="Subtitle 2">
             <a:extLst>
               <a:ext uri="{FF2B5EF4-FFF2-40B4-BE49-F238E27FC236}">
-                <a16:creationId xmlns:a16="http://schemas.microsoft.com/office/drawing/2014/main" id="{F3DB978E-829E-D2A8-8C34-D3A0EA5190B3}"/>
+                <a16:creationId xmlns:a16="http://schemas.microsoft.com/office/drawing/2014/main" id="{679D33CE-A028-0EC9-49B3-E92D8EC7A459}"/>
               </a:ext>
             </a:extLst>
           </p:cNvPr>
@@ -245,7 +243,7 @@
           <p:cNvPr id="4" name="Date Placeholder 3">
             <a:extLst>
               <a:ext uri="{FF2B5EF4-FFF2-40B4-BE49-F238E27FC236}">
-                <a16:creationId xmlns:a16="http://schemas.microsoft.com/office/drawing/2014/main" id="{5AF8B8CC-C468-D4CE-2BD1-6526715CFF86}"/>
+                <a16:creationId xmlns:a16="http://schemas.microsoft.com/office/drawing/2014/main" id="{9D40D6F6-0A1B-45D5-F2B1-4652FDEB2171}"/>
               </a:ext>
             </a:extLst>
           </p:cNvPr>
@@ -274,7 +272,7 @@
           <p:cNvPr id="5" name="Footer Placeholder 4">
             <a:extLst>
               <a:ext uri="{FF2B5EF4-FFF2-40B4-BE49-F238E27FC236}">
-                <a16:creationId xmlns:a16="http://schemas.microsoft.com/office/drawing/2014/main" id="{5FD490FE-FCE0-9F22-A8D7-A784A95C88C7}"/>
+                <a16:creationId xmlns:a16="http://schemas.microsoft.com/office/drawing/2014/main" id="{DE2EBE07-4B45-8EF6-4C09-72E667F27A26}"/>
               </a:ext>
             </a:extLst>
           </p:cNvPr>
@@ -299,7 +297,7 @@
           <p:cNvPr id="6" name="Slide Number Placeholder 5">
             <a:extLst>
               <a:ext uri="{FF2B5EF4-FFF2-40B4-BE49-F238E27FC236}">
-                <a16:creationId xmlns:a16="http://schemas.microsoft.com/office/drawing/2014/main" id="{C7A05FF6-51F4-1742-04B2-66CE8955CAA6}"/>
+                <a16:creationId xmlns:a16="http://schemas.microsoft.com/office/drawing/2014/main" id="{DF849B99-A1CC-5EFF-6614-D3D4799A4FCA}"/>
               </a:ext>
             </a:extLst>
           </p:cNvPr>
@@ -326,7 +324,7 @@
     </p:spTree>
     <p:extLst>
       <p:ext uri="{BB962C8B-B14F-4D97-AF65-F5344CB8AC3E}">
-        <p14:creationId xmlns:p14="http://schemas.microsoft.com/office/powerpoint/2010/main" val="219352218"/>
+        <p14:creationId xmlns:p14="http://schemas.microsoft.com/office/powerpoint/2010/main" val="2988694020"/>
       </p:ext>
     </p:extLst>
   </p:cSld>
@@ -358,7 +356,7 @@
           <p:cNvPr id="2" name="Title 1">
             <a:extLst>
               <a:ext uri="{FF2B5EF4-FFF2-40B4-BE49-F238E27FC236}">
-                <a16:creationId xmlns:a16="http://schemas.microsoft.com/office/drawing/2014/main" id="{49996A57-AEDD-8E6D-EBB0-82CF43D70BAF}"/>
+                <a16:creationId xmlns:a16="http://schemas.microsoft.com/office/drawing/2014/main" id="{D0AF75BF-800D-75C6-4676-5F80B3DAB227}"/>
               </a:ext>
             </a:extLst>
           </p:cNvPr>
@@ -386,7 +384,7 @@
           <p:cNvPr id="3" name="Vertical Text Placeholder 2">
             <a:extLst>
               <a:ext uri="{FF2B5EF4-FFF2-40B4-BE49-F238E27FC236}">
-                <a16:creationId xmlns:a16="http://schemas.microsoft.com/office/drawing/2014/main" id="{ABFDDA95-3F7E-9147-0236-44800618A175}"/>
+                <a16:creationId xmlns:a16="http://schemas.microsoft.com/office/drawing/2014/main" id="{39867432-4E28-FC3B-938F-B5C2B1FEEF39}"/>
               </a:ext>
             </a:extLst>
           </p:cNvPr>
@@ -443,7 +441,7 @@
           <p:cNvPr id="4" name="Date Placeholder 3">
             <a:extLst>
               <a:ext uri="{FF2B5EF4-FFF2-40B4-BE49-F238E27FC236}">
-                <a16:creationId xmlns:a16="http://schemas.microsoft.com/office/drawing/2014/main" id="{C20E62DA-9627-3CE4-CD64-ECF39FF57EB3}"/>
+                <a16:creationId xmlns:a16="http://schemas.microsoft.com/office/drawing/2014/main" id="{4D67AE03-A513-67FA-205D-E5736371EDC7}"/>
               </a:ext>
             </a:extLst>
           </p:cNvPr>
@@ -472,7 +470,7 @@
           <p:cNvPr id="5" name="Footer Placeholder 4">
             <a:extLst>
               <a:ext uri="{FF2B5EF4-FFF2-40B4-BE49-F238E27FC236}">
-                <a16:creationId xmlns:a16="http://schemas.microsoft.com/office/drawing/2014/main" id="{E61140A9-A203-F965-C501-EED034B67581}"/>
+                <a16:creationId xmlns:a16="http://schemas.microsoft.com/office/drawing/2014/main" id="{6B879708-C1A9-39D6-8B56-7E28061E4CA6}"/>
               </a:ext>
             </a:extLst>
           </p:cNvPr>
@@ -497,7 +495,7 @@
           <p:cNvPr id="6" name="Slide Number Placeholder 5">
             <a:extLst>
               <a:ext uri="{FF2B5EF4-FFF2-40B4-BE49-F238E27FC236}">
-                <a16:creationId xmlns:a16="http://schemas.microsoft.com/office/drawing/2014/main" id="{9E8469FF-C137-AD53-8DDB-811BDB6C972D}"/>
+                <a16:creationId xmlns:a16="http://schemas.microsoft.com/office/drawing/2014/main" id="{7AB76839-D343-FF8E-5FEC-4AFAA05A21CB}"/>
               </a:ext>
             </a:extLst>
           </p:cNvPr>
@@ -524,7 +522,7 @@
     </p:spTree>
     <p:extLst>
       <p:ext uri="{BB962C8B-B14F-4D97-AF65-F5344CB8AC3E}">
-        <p14:creationId xmlns:p14="http://schemas.microsoft.com/office/powerpoint/2010/main" val="2708505336"/>
+        <p14:creationId xmlns:p14="http://schemas.microsoft.com/office/powerpoint/2010/main" val="2884022136"/>
       </p:ext>
     </p:extLst>
   </p:cSld>
@@ -556,7 +554,7 @@
           <p:cNvPr id="2" name="Vertical Title 1">
             <a:extLst>
               <a:ext uri="{FF2B5EF4-FFF2-40B4-BE49-F238E27FC236}">
-                <a16:creationId xmlns:a16="http://schemas.microsoft.com/office/drawing/2014/main" id="{953804D7-F4BD-8D93-6886-9BBDB4CB1610}"/>
+                <a16:creationId xmlns:a16="http://schemas.microsoft.com/office/drawing/2014/main" id="{BECAE7A8-1FED-5C29-453D-912ED042B98A}"/>
               </a:ext>
             </a:extLst>
           </p:cNvPr>
@@ -589,7 +587,7 @@
           <p:cNvPr id="3" name="Vertical Text Placeholder 2">
             <a:extLst>
               <a:ext uri="{FF2B5EF4-FFF2-40B4-BE49-F238E27FC236}">
-                <a16:creationId xmlns:a16="http://schemas.microsoft.com/office/drawing/2014/main" id="{E0E0D756-F960-47D4-B481-77EBD575DC31}"/>
+                <a16:creationId xmlns:a16="http://schemas.microsoft.com/office/drawing/2014/main" id="{448FE1DF-8070-CA89-5812-87A89B0D4103}"/>
               </a:ext>
             </a:extLst>
           </p:cNvPr>
@@ -651,7 +649,7 @@
           <p:cNvPr id="4" name="Date Placeholder 3">
             <a:extLst>
               <a:ext uri="{FF2B5EF4-FFF2-40B4-BE49-F238E27FC236}">
-                <a16:creationId xmlns:a16="http://schemas.microsoft.com/office/drawing/2014/main" id="{62751D16-554E-DD8C-D63B-7A7C12CBB250}"/>
+                <a16:creationId xmlns:a16="http://schemas.microsoft.com/office/drawing/2014/main" id="{CE0282FF-5F96-0ECD-E73F-433BDE4A8718}"/>
               </a:ext>
             </a:extLst>
           </p:cNvPr>
@@ -680,7 +678,7 @@
           <p:cNvPr id="5" name="Footer Placeholder 4">
             <a:extLst>
               <a:ext uri="{FF2B5EF4-FFF2-40B4-BE49-F238E27FC236}">
-                <a16:creationId xmlns:a16="http://schemas.microsoft.com/office/drawing/2014/main" id="{05E6AE53-FC06-081D-5096-BC577082EF5E}"/>
+                <a16:creationId xmlns:a16="http://schemas.microsoft.com/office/drawing/2014/main" id="{2D975990-8A28-2ED1-F880-DF86B348DDC6}"/>
               </a:ext>
             </a:extLst>
           </p:cNvPr>
@@ -705,7 +703,7 @@
           <p:cNvPr id="6" name="Slide Number Placeholder 5">
             <a:extLst>
               <a:ext uri="{FF2B5EF4-FFF2-40B4-BE49-F238E27FC236}">
-                <a16:creationId xmlns:a16="http://schemas.microsoft.com/office/drawing/2014/main" id="{4D532E8B-C64B-493D-0D81-BD487B93341F}"/>
+                <a16:creationId xmlns:a16="http://schemas.microsoft.com/office/drawing/2014/main" id="{B9E02802-55C7-28B5-3FF7-9450C79DBCB1}"/>
               </a:ext>
             </a:extLst>
           </p:cNvPr>
@@ -732,7 +730,7 @@
     </p:spTree>
     <p:extLst>
       <p:ext uri="{BB962C8B-B14F-4D97-AF65-F5344CB8AC3E}">
-        <p14:creationId xmlns:p14="http://schemas.microsoft.com/office/powerpoint/2010/main" val="2665192629"/>
+        <p14:creationId xmlns:p14="http://schemas.microsoft.com/office/powerpoint/2010/main" val="2754779964"/>
       </p:ext>
     </p:extLst>
   </p:cSld>
@@ -764,7 +762,7 @@
           <p:cNvPr id="2" name="Title 1">
             <a:extLst>
               <a:ext uri="{FF2B5EF4-FFF2-40B4-BE49-F238E27FC236}">
-                <a16:creationId xmlns:a16="http://schemas.microsoft.com/office/drawing/2014/main" id="{862E004E-C8AF-0777-330B-2FEB5AFE2AB9}"/>
+                <a16:creationId xmlns:a16="http://schemas.microsoft.com/office/drawing/2014/main" id="{5E7B5D26-C11A-B934-7673-A779E28F7F3A}"/>
               </a:ext>
             </a:extLst>
           </p:cNvPr>
@@ -792,7 +790,7 @@
           <p:cNvPr id="3" name="Content Placeholder 2">
             <a:extLst>
               <a:ext uri="{FF2B5EF4-FFF2-40B4-BE49-F238E27FC236}">
-                <a16:creationId xmlns:a16="http://schemas.microsoft.com/office/drawing/2014/main" id="{9612CC89-77C0-921A-34A4-9F35C70A7E42}"/>
+                <a16:creationId xmlns:a16="http://schemas.microsoft.com/office/drawing/2014/main" id="{B55B9A35-9A7C-3233-CA23-EF53F827265E}"/>
               </a:ext>
             </a:extLst>
           </p:cNvPr>
@@ -849,7 +847,7 @@
           <p:cNvPr id="4" name="Date Placeholder 3">
             <a:extLst>
               <a:ext uri="{FF2B5EF4-FFF2-40B4-BE49-F238E27FC236}">
-                <a16:creationId xmlns:a16="http://schemas.microsoft.com/office/drawing/2014/main" id="{A3715CE1-88A3-D3A2-7C64-669174824242}"/>
+                <a16:creationId xmlns:a16="http://schemas.microsoft.com/office/drawing/2014/main" id="{0F77B2A1-5485-E611-6EFD-F51791135384}"/>
               </a:ext>
             </a:extLst>
           </p:cNvPr>
@@ -878,7 +876,7 @@
           <p:cNvPr id="5" name="Footer Placeholder 4">
             <a:extLst>
               <a:ext uri="{FF2B5EF4-FFF2-40B4-BE49-F238E27FC236}">
-                <a16:creationId xmlns:a16="http://schemas.microsoft.com/office/drawing/2014/main" id="{D0B737A5-6802-9C23-7676-9D84223840F5}"/>
+                <a16:creationId xmlns:a16="http://schemas.microsoft.com/office/drawing/2014/main" id="{3DC5D52B-5BF2-82AF-D313-7DD1D11D9122}"/>
               </a:ext>
             </a:extLst>
           </p:cNvPr>
@@ -903,7 +901,7 @@
           <p:cNvPr id="6" name="Slide Number Placeholder 5">
             <a:extLst>
               <a:ext uri="{FF2B5EF4-FFF2-40B4-BE49-F238E27FC236}">
-                <a16:creationId xmlns:a16="http://schemas.microsoft.com/office/drawing/2014/main" id="{B252C30D-3473-2B58-6BA2-2BAD1A05EC7B}"/>
+                <a16:creationId xmlns:a16="http://schemas.microsoft.com/office/drawing/2014/main" id="{0DCCE068-7171-412D-57BF-44AAF307BBE0}"/>
               </a:ext>
             </a:extLst>
           </p:cNvPr>
@@ -930,7 +928,7 @@
     </p:spTree>
     <p:extLst>
       <p:ext uri="{BB962C8B-B14F-4D97-AF65-F5344CB8AC3E}">
-        <p14:creationId xmlns:p14="http://schemas.microsoft.com/office/powerpoint/2010/main" val="41498427"/>
+        <p14:creationId xmlns:p14="http://schemas.microsoft.com/office/powerpoint/2010/main" val="869023287"/>
       </p:ext>
     </p:extLst>
   </p:cSld>
@@ -962,7 +960,7 @@
           <p:cNvPr id="2" name="Title 1">
             <a:extLst>
               <a:ext uri="{FF2B5EF4-FFF2-40B4-BE49-F238E27FC236}">
-                <a16:creationId xmlns:a16="http://schemas.microsoft.com/office/drawing/2014/main" id="{2CCB88AE-4108-CF99-D886-F0EEC24CF915}"/>
+                <a16:creationId xmlns:a16="http://schemas.microsoft.com/office/drawing/2014/main" id="{4FCC2542-9FDA-6D6B-D47E-0DDA3485131A}"/>
               </a:ext>
             </a:extLst>
           </p:cNvPr>
@@ -999,7 +997,7 @@
           <p:cNvPr id="3" name="Text Placeholder 2">
             <a:extLst>
               <a:ext uri="{FF2B5EF4-FFF2-40B4-BE49-F238E27FC236}">
-                <a16:creationId xmlns:a16="http://schemas.microsoft.com/office/drawing/2014/main" id="{20BEC784-08C8-2B16-536D-466A6510DE0F}"/>
+                <a16:creationId xmlns:a16="http://schemas.microsoft.com/office/drawing/2014/main" id="{9A6F4D72-5EFD-B43A-9932-9B8F90FB1D50}"/>
               </a:ext>
             </a:extLst>
           </p:cNvPr>
@@ -1124,7 +1122,7 @@
           <p:cNvPr id="4" name="Date Placeholder 3">
             <a:extLst>
               <a:ext uri="{FF2B5EF4-FFF2-40B4-BE49-F238E27FC236}">
-                <a16:creationId xmlns:a16="http://schemas.microsoft.com/office/drawing/2014/main" id="{246640BF-BBF5-2B8C-1843-B35974063510}"/>
+                <a16:creationId xmlns:a16="http://schemas.microsoft.com/office/drawing/2014/main" id="{56D762BC-FD82-FF7E-E165-BEC1C698281F}"/>
               </a:ext>
             </a:extLst>
           </p:cNvPr>
@@ -1153,7 +1151,7 @@
           <p:cNvPr id="5" name="Footer Placeholder 4">
             <a:extLst>
               <a:ext uri="{FF2B5EF4-FFF2-40B4-BE49-F238E27FC236}">
-                <a16:creationId xmlns:a16="http://schemas.microsoft.com/office/drawing/2014/main" id="{C020B855-0CE1-F089-3C42-FA0555800F95}"/>
+                <a16:creationId xmlns:a16="http://schemas.microsoft.com/office/drawing/2014/main" id="{086F4B9A-F770-4F73-2BF7-C6F8A584CD98}"/>
               </a:ext>
             </a:extLst>
           </p:cNvPr>
@@ -1178,7 +1176,7 @@
           <p:cNvPr id="6" name="Slide Number Placeholder 5">
             <a:extLst>
               <a:ext uri="{FF2B5EF4-FFF2-40B4-BE49-F238E27FC236}">
-                <a16:creationId xmlns:a16="http://schemas.microsoft.com/office/drawing/2014/main" id="{8F6F17FE-438A-609B-319F-7C52C2D6FFDE}"/>
+                <a16:creationId xmlns:a16="http://schemas.microsoft.com/office/drawing/2014/main" id="{CDE8B207-BCFD-1FF6-CFF0-F5B4F81E4E65}"/>
               </a:ext>
             </a:extLst>
           </p:cNvPr>
@@ -1205,7 +1203,7 @@
     </p:spTree>
     <p:extLst>
       <p:ext uri="{BB962C8B-B14F-4D97-AF65-F5344CB8AC3E}">
-        <p14:creationId xmlns:p14="http://schemas.microsoft.com/office/powerpoint/2010/main" val="333472875"/>
+        <p14:creationId xmlns:p14="http://schemas.microsoft.com/office/powerpoint/2010/main" val="3390412553"/>
       </p:ext>
     </p:extLst>
   </p:cSld>
@@ -1237,7 +1235,7 @@
           <p:cNvPr id="2" name="Title 1">
             <a:extLst>
               <a:ext uri="{FF2B5EF4-FFF2-40B4-BE49-F238E27FC236}">
-                <a16:creationId xmlns:a16="http://schemas.microsoft.com/office/drawing/2014/main" id="{31BB2ACF-A609-CF85-A7C6-619AB3907DB3}"/>
+                <a16:creationId xmlns:a16="http://schemas.microsoft.com/office/drawing/2014/main" id="{2A60866C-5E71-68AE-0A43-6E78B0A7ECFA}"/>
               </a:ext>
             </a:extLst>
           </p:cNvPr>
@@ -1265,7 +1263,7 @@
           <p:cNvPr id="3" name="Content Placeholder 2">
             <a:extLst>
               <a:ext uri="{FF2B5EF4-FFF2-40B4-BE49-F238E27FC236}">
-                <a16:creationId xmlns:a16="http://schemas.microsoft.com/office/drawing/2014/main" id="{0E3B9F3B-6AED-9AF3-E8FB-9E03A6A066B8}"/>
+                <a16:creationId xmlns:a16="http://schemas.microsoft.com/office/drawing/2014/main" id="{2875663F-E2BE-F42C-0769-0819950C419B}"/>
               </a:ext>
             </a:extLst>
           </p:cNvPr>
@@ -1327,7 +1325,7 @@
           <p:cNvPr id="4" name="Content Placeholder 3">
             <a:extLst>
               <a:ext uri="{FF2B5EF4-FFF2-40B4-BE49-F238E27FC236}">
-                <a16:creationId xmlns:a16="http://schemas.microsoft.com/office/drawing/2014/main" id="{DF47ADED-13C5-0F5F-8F9C-0489461E720D}"/>
+                <a16:creationId xmlns:a16="http://schemas.microsoft.com/office/drawing/2014/main" id="{3FEBE451-BAC3-77D4-E9D6-D506D3518D98}"/>
               </a:ext>
             </a:extLst>
           </p:cNvPr>
@@ -1389,7 +1387,7 @@
           <p:cNvPr id="5" name="Date Placeholder 4">
             <a:extLst>
               <a:ext uri="{FF2B5EF4-FFF2-40B4-BE49-F238E27FC236}">
-                <a16:creationId xmlns:a16="http://schemas.microsoft.com/office/drawing/2014/main" id="{6354A97F-3924-D870-8B79-2EAA1F9DC8B3}"/>
+                <a16:creationId xmlns:a16="http://schemas.microsoft.com/office/drawing/2014/main" id="{2B02DE28-4638-DAE1-017B-ABAE8522771B}"/>
               </a:ext>
             </a:extLst>
           </p:cNvPr>
@@ -1418,7 +1416,7 @@
           <p:cNvPr id="6" name="Footer Placeholder 5">
             <a:extLst>
               <a:ext uri="{FF2B5EF4-FFF2-40B4-BE49-F238E27FC236}">
-                <a16:creationId xmlns:a16="http://schemas.microsoft.com/office/drawing/2014/main" id="{D1606977-FCC3-5E22-498B-66025517815A}"/>
+                <a16:creationId xmlns:a16="http://schemas.microsoft.com/office/drawing/2014/main" id="{7D0E380C-FCAF-E006-A680-318BB3830D65}"/>
               </a:ext>
             </a:extLst>
           </p:cNvPr>
@@ -1443,7 +1441,7 @@
           <p:cNvPr id="7" name="Slide Number Placeholder 6">
             <a:extLst>
               <a:ext uri="{FF2B5EF4-FFF2-40B4-BE49-F238E27FC236}">
-                <a16:creationId xmlns:a16="http://schemas.microsoft.com/office/drawing/2014/main" id="{0A105749-221A-062A-FB2B-4D16B9D461B6}"/>
+                <a16:creationId xmlns:a16="http://schemas.microsoft.com/office/drawing/2014/main" id="{877C5411-F9F0-5570-8D2F-90CF63219F72}"/>
               </a:ext>
             </a:extLst>
           </p:cNvPr>
@@ -1470,7 +1468,7 @@
     </p:spTree>
     <p:extLst>
       <p:ext uri="{BB962C8B-B14F-4D97-AF65-F5344CB8AC3E}">
-        <p14:creationId xmlns:p14="http://schemas.microsoft.com/office/powerpoint/2010/main" val="2224877369"/>
+        <p14:creationId xmlns:p14="http://schemas.microsoft.com/office/powerpoint/2010/main" val="2134898290"/>
       </p:ext>
     </p:extLst>
   </p:cSld>
@@ -1502,7 +1500,7 @@
           <p:cNvPr id="2" name="Title 1">
             <a:extLst>
               <a:ext uri="{FF2B5EF4-FFF2-40B4-BE49-F238E27FC236}">
-                <a16:creationId xmlns:a16="http://schemas.microsoft.com/office/drawing/2014/main" id="{8A562DAA-85A4-E958-7BCC-2E4AB92C30BF}"/>
+                <a16:creationId xmlns:a16="http://schemas.microsoft.com/office/drawing/2014/main" id="{8DBC7982-5B1A-8EF0-ABC9-1E8ADE6571EF}"/>
               </a:ext>
             </a:extLst>
           </p:cNvPr>
@@ -1535,7 +1533,7 @@
           <p:cNvPr id="3" name="Text Placeholder 2">
             <a:extLst>
               <a:ext uri="{FF2B5EF4-FFF2-40B4-BE49-F238E27FC236}">
-                <a16:creationId xmlns:a16="http://schemas.microsoft.com/office/drawing/2014/main" id="{1E9B87EB-A277-1C34-0C38-85AA58D83339}"/>
+                <a16:creationId xmlns:a16="http://schemas.microsoft.com/office/drawing/2014/main" id="{EC795EAA-5F5D-785B-2935-EF3D4458E571}"/>
               </a:ext>
             </a:extLst>
           </p:cNvPr>
@@ -1606,7 +1604,7 @@
           <p:cNvPr id="4" name="Content Placeholder 3">
             <a:extLst>
               <a:ext uri="{FF2B5EF4-FFF2-40B4-BE49-F238E27FC236}">
-                <a16:creationId xmlns:a16="http://schemas.microsoft.com/office/drawing/2014/main" id="{1F677859-A5E8-4B5E-BB04-EFF222DADD9F}"/>
+                <a16:creationId xmlns:a16="http://schemas.microsoft.com/office/drawing/2014/main" id="{B3A2F789-BC2B-8E5F-DDC0-E4E40E877B2A}"/>
               </a:ext>
             </a:extLst>
           </p:cNvPr>
@@ -1668,7 +1666,7 @@
           <p:cNvPr id="5" name="Text Placeholder 4">
             <a:extLst>
               <a:ext uri="{FF2B5EF4-FFF2-40B4-BE49-F238E27FC236}">
-                <a16:creationId xmlns:a16="http://schemas.microsoft.com/office/drawing/2014/main" id="{7789F8DF-D853-30EB-6485-BA44DC29439C}"/>
+                <a16:creationId xmlns:a16="http://schemas.microsoft.com/office/drawing/2014/main" id="{A6016B06-B1DB-344B-0830-2DABDE9AF820}"/>
               </a:ext>
             </a:extLst>
           </p:cNvPr>
@@ -1739,7 +1737,7 @@
           <p:cNvPr id="6" name="Content Placeholder 5">
             <a:extLst>
               <a:ext uri="{FF2B5EF4-FFF2-40B4-BE49-F238E27FC236}">
-                <a16:creationId xmlns:a16="http://schemas.microsoft.com/office/drawing/2014/main" id="{2AA2BE02-CC4D-2DF3-EA98-34872C43D5E5}"/>
+                <a16:creationId xmlns:a16="http://schemas.microsoft.com/office/drawing/2014/main" id="{A7834CF9-F280-B478-0FCC-DF58F6BFE9C9}"/>
               </a:ext>
             </a:extLst>
           </p:cNvPr>
@@ -1801,7 +1799,7 @@
           <p:cNvPr id="7" name="Date Placeholder 6">
             <a:extLst>
               <a:ext uri="{FF2B5EF4-FFF2-40B4-BE49-F238E27FC236}">
-                <a16:creationId xmlns:a16="http://schemas.microsoft.com/office/drawing/2014/main" id="{432D0C07-57EB-8710-6EE2-1603BAD5E458}"/>
+                <a16:creationId xmlns:a16="http://schemas.microsoft.com/office/drawing/2014/main" id="{185F00D9-415B-C829-14C4-92690D764523}"/>
               </a:ext>
             </a:extLst>
           </p:cNvPr>
@@ -1830,7 +1828,7 @@
           <p:cNvPr id="8" name="Footer Placeholder 7">
             <a:extLst>
               <a:ext uri="{FF2B5EF4-FFF2-40B4-BE49-F238E27FC236}">
-                <a16:creationId xmlns:a16="http://schemas.microsoft.com/office/drawing/2014/main" id="{FBB3D5EF-D538-4C09-AE39-83CB9A77D5F4}"/>
+                <a16:creationId xmlns:a16="http://schemas.microsoft.com/office/drawing/2014/main" id="{DB9ADECF-A892-6A88-809F-BD00879F00E9}"/>
               </a:ext>
             </a:extLst>
           </p:cNvPr>
@@ -1855,7 +1853,7 @@
           <p:cNvPr id="9" name="Slide Number Placeholder 8">
             <a:extLst>
               <a:ext uri="{FF2B5EF4-FFF2-40B4-BE49-F238E27FC236}">
-                <a16:creationId xmlns:a16="http://schemas.microsoft.com/office/drawing/2014/main" id="{09B288F4-B13C-0FB7-DB52-8CE4708E58C6}"/>
+                <a16:creationId xmlns:a16="http://schemas.microsoft.com/office/drawing/2014/main" id="{C9397252-5042-0773-051C-CA0D78D20738}"/>
               </a:ext>
             </a:extLst>
           </p:cNvPr>
@@ -1882,7 +1880,7 @@
     </p:spTree>
     <p:extLst>
       <p:ext uri="{BB962C8B-B14F-4D97-AF65-F5344CB8AC3E}">
-        <p14:creationId xmlns:p14="http://schemas.microsoft.com/office/powerpoint/2010/main" val="2320362217"/>
+        <p14:creationId xmlns:p14="http://schemas.microsoft.com/office/powerpoint/2010/main" val="896236985"/>
       </p:ext>
     </p:extLst>
   </p:cSld>
@@ -1914,7 +1912,7 @@
           <p:cNvPr id="2" name="Title 1">
             <a:extLst>
               <a:ext uri="{FF2B5EF4-FFF2-40B4-BE49-F238E27FC236}">
-                <a16:creationId xmlns:a16="http://schemas.microsoft.com/office/drawing/2014/main" id="{6DD4FDA8-9799-F3D7-17F4-1E238481E465}"/>
+                <a16:creationId xmlns:a16="http://schemas.microsoft.com/office/drawing/2014/main" id="{5DB2DB60-B4D2-9512-AD46-59D875C4FCD5}"/>
               </a:ext>
             </a:extLst>
           </p:cNvPr>
@@ -1942,7 +1940,7 @@
           <p:cNvPr id="3" name="Date Placeholder 2">
             <a:extLst>
               <a:ext uri="{FF2B5EF4-FFF2-40B4-BE49-F238E27FC236}">
-                <a16:creationId xmlns:a16="http://schemas.microsoft.com/office/drawing/2014/main" id="{89CBB4FD-BD87-1E05-8B11-694061C90C4D}"/>
+                <a16:creationId xmlns:a16="http://schemas.microsoft.com/office/drawing/2014/main" id="{CC1444C9-29DD-00E9-7BEB-E639680CB311}"/>
               </a:ext>
             </a:extLst>
           </p:cNvPr>
@@ -1971,7 +1969,7 @@
           <p:cNvPr id="4" name="Footer Placeholder 3">
             <a:extLst>
               <a:ext uri="{FF2B5EF4-FFF2-40B4-BE49-F238E27FC236}">
-                <a16:creationId xmlns:a16="http://schemas.microsoft.com/office/drawing/2014/main" id="{09D1EEAD-24CB-A7B9-C9F8-10D25F05B692}"/>
+                <a16:creationId xmlns:a16="http://schemas.microsoft.com/office/drawing/2014/main" id="{5033F175-AC94-3424-865D-7D4B8905A38C}"/>
               </a:ext>
             </a:extLst>
           </p:cNvPr>
@@ -1996,7 +1994,7 @@
           <p:cNvPr id="5" name="Slide Number Placeholder 4">
             <a:extLst>
               <a:ext uri="{FF2B5EF4-FFF2-40B4-BE49-F238E27FC236}">
-                <a16:creationId xmlns:a16="http://schemas.microsoft.com/office/drawing/2014/main" id="{A98AFAC5-7257-2C41-3DC6-C18B944CFB5A}"/>
+                <a16:creationId xmlns:a16="http://schemas.microsoft.com/office/drawing/2014/main" id="{8AF2A379-A350-C853-C2C9-92BB9DCDA84A}"/>
               </a:ext>
             </a:extLst>
           </p:cNvPr>
@@ -2023,7 +2021,7 @@
     </p:spTree>
     <p:extLst>
       <p:ext uri="{BB962C8B-B14F-4D97-AF65-F5344CB8AC3E}">
-        <p14:creationId xmlns:p14="http://schemas.microsoft.com/office/powerpoint/2010/main" val="4275927964"/>
+        <p14:creationId xmlns:p14="http://schemas.microsoft.com/office/powerpoint/2010/main" val="1693249179"/>
       </p:ext>
     </p:extLst>
   </p:cSld>
@@ -2055,7 +2053,7 @@
           <p:cNvPr id="2" name="Date Placeholder 1">
             <a:extLst>
               <a:ext uri="{FF2B5EF4-FFF2-40B4-BE49-F238E27FC236}">
-                <a16:creationId xmlns:a16="http://schemas.microsoft.com/office/drawing/2014/main" id="{6C85114D-1C87-E3C8-188B-0DF869A06D8F}"/>
+                <a16:creationId xmlns:a16="http://schemas.microsoft.com/office/drawing/2014/main" id="{01744C9D-2CEF-BA88-C1EB-EE53B6309CAC}"/>
               </a:ext>
             </a:extLst>
           </p:cNvPr>
@@ -2084,7 +2082,7 @@
           <p:cNvPr id="3" name="Footer Placeholder 2">
             <a:extLst>
               <a:ext uri="{FF2B5EF4-FFF2-40B4-BE49-F238E27FC236}">
-                <a16:creationId xmlns:a16="http://schemas.microsoft.com/office/drawing/2014/main" id="{04CA3821-E836-A68E-D0BE-E6193935E0AF}"/>
+                <a16:creationId xmlns:a16="http://schemas.microsoft.com/office/drawing/2014/main" id="{057AF285-ED87-C118-CF5F-7ACD2A5696DF}"/>
               </a:ext>
             </a:extLst>
           </p:cNvPr>
@@ -2109,7 +2107,7 @@
           <p:cNvPr id="4" name="Slide Number Placeholder 3">
             <a:extLst>
               <a:ext uri="{FF2B5EF4-FFF2-40B4-BE49-F238E27FC236}">
-                <a16:creationId xmlns:a16="http://schemas.microsoft.com/office/drawing/2014/main" id="{88967C21-F9CD-AF09-F6F3-9BF3E7C5B940}"/>
+                <a16:creationId xmlns:a16="http://schemas.microsoft.com/office/drawing/2014/main" id="{F2107CA8-2E7D-3CBA-0D46-4A61BFA61C61}"/>
               </a:ext>
             </a:extLst>
           </p:cNvPr>
@@ -2136,7 +2134,7 @@
     </p:spTree>
     <p:extLst>
       <p:ext uri="{BB962C8B-B14F-4D97-AF65-F5344CB8AC3E}">
-        <p14:creationId xmlns:p14="http://schemas.microsoft.com/office/powerpoint/2010/main" val="1190275884"/>
+        <p14:creationId xmlns:p14="http://schemas.microsoft.com/office/powerpoint/2010/main" val="3954871541"/>
       </p:ext>
     </p:extLst>
   </p:cSld>
@@ -2168,7 +2166,7 @@
           <p:cNvPr id="2" name="Title 1">
             <a:extLst>
               <a:ext uri="{FF2B5EF4-FFF2-40B4-BE49-F238E27FC236}">
-                <a16:creationId xmlns:a16="http://schemas.microsoft.com/office/drawing/2014/main" id="{0D19D1E4-252D-C10D-7C59-FFB7CABD7795}"/>
+                <a16:creationId xmlns:a16="http://schemas.microsoft.com/office/drawing/2014/main" id="{0F6F86BA-1CDC-4807-50F5-71AEEB60AAAE}"/>
               </a:ext>
             </a:extLst>
           </p:cNvPr>
@@ -2205,7 +2203,7 @@
           <p:cNvPr id="3" name="Content Placeholder 2">
             <a:extLst>
               <a:ext uri="{FF2B5EF4-FFF2-40B4-BE49-F238E27FC236}">
-                <a16:creationId xmlns:a16="http://schemas.microsoft.com/office/drawing/2014/main" id="{72E8FA94-86D5-499E-E186-AA5CF15853FD}"/>
+                <a16:creationId xmlns:a16="http://schemas.microsoft.com/office/drawing/2014/main" id="{739E806E-50E0-3447-9865-3EFF7197C597}"/>
               </a:ext>
             </a:extLst>
           </p:cNvPr>
@@ -2295,7 +2293,7 @@
           <p:cNvPr id="4" name="Text Placeholder 3">
             <a:extLst>
               <a:ext uri="{FF2B5EF4-FFF2-40B4-BE49-F238E27FC236}">
-                <a16:creationId xmlns:a16="http://schemas.microsoft.com/office/drawing/2014/main" id="{993AFF8E-08BC-1508-79FD-AD9C8C8E6967}"/>
+                <a16:creationId xmlns:a16="http://schemas.microsoft.com/office/drawing/2014/main" id="{CE54EA0E-51D9-3DC2-FE14-546B00C6576B}"/>
               </a:ext>
             </a:extLst>
           </p:cNvPr>
@@ -2366,7 +2364,7 @@
           <p:cNvPr id="5" name="Date Placeholder 4">
             <a:extLst>
               <a:ext uri="{FF2B5EF4-FFF2-40B4-BE49-F238E27FC236}">
-                <a16:creationId xmlns:a16="http://schemas.microsoft.com/office/drawing/2014/main" id="{BB3178AE-7633-3C36-F543-2566B5797148}"/>
+                <a16:creationId xmlns:a16="http://schemas.microsoft.com/office/drawing/2014/main" id="{6A01FAD8-5EF4-0E02-E4C2-DC976E0C6C31}"/>
               </a:ext>
             </a:extLst>
           </p:cNvPr>
@@ -2395,7 +2393,7 @@
           <p:cNvPr id="6" name="Footer Placeholder 5">
             <a:extLst>
               <a:ext uri="{FF2B5EF4-FFF2-40B4-BE49-F238E27FC236}">
-                <a16:creationId xmlns:a16="http://schemas.microsoft.com/office/drawing/2014/main" id="{AB1D674D-0ECD-A91F-E902-BB58A0D4C5B8}"/>
+                <a16:creationId xmlns:a16="http://schemas.microsoft.com/office/drawing/2014/main" id="{78A317B6-EC40-87EF-1685-F6C665E54C07}"/>
               </a:ext>
             </a:extLst>
           </p:cNvPr>
@@ -2420,7 +2418,7 @@
           <p:cNvPr id="7" name="Slide Number Placeholder 6">
             <a:extLst>
               <a:ext uri="{FF2B5EF4-FFF2-40B4-BE49-F238E27FC236}">
-                <a16:creationId xmlns:a16="http://schemas.microsoft.com/office/drawing/2014/main" id="{BCDABABA-874D-B381-9462-0AB8154144A3}"/>
+                <a16:creationId xmlns:a16="http://schemas.microsoft.com/office/drawing/2014/main" id="{F66709BA-C660-C4B7-4B69-9E42CBFB6535}"/>
               </a:ext>
             </a:extLst>
           </p:cNvPr>
@@ -2447,7 +2445,7 @@
     </p:spTree>
     <p:extLst>
       <p:ext uri="{BB962C8B-B14F-4D97-AF65-F5344CB8AC3E}">
-        <p14:creationId xmlns:p14="http://schemas.microsoft.com/office/powerpoint/2010/main" val="3404472830"/>
+        <p14:creationId xmlns:p14="http://schemas.microsoft.com/office/powerpoint/2010/main" val="799628581"/>
       </p:ext>
     </p:extLst>
   </p:cSld>
@@ -2479,7 +2477,7 @@
           <p:cNvPr id="2" name="Title 1">
             <a:extLst>
               <a:ext uri="{FF2B5EF4-FFF2-40B4-BE49-F238E27FC236}">
-                <a16:creationId xmlns:a16="http://schemas.microsoft.com/office/drawing/2014/main" id="{1E06EA82-10A3-349B-EBED-DD9901DCC294}"/>
+                <a16:creationId xmlns:a16="http://schemas.microsoft.com/office/drawing/2014/main" id="{065AF38A-5DDE-1ED9-041A-DF90B9537667}"/>
               </a:ext>
             </a:extLst>
           </p:cNvPr>
@@ -2516,7 +2514,7 @@
           <p:cNvPr id="3" name="Picture Placeholder 2">
             <a:extLst>
               <a:ext uri="{FF2B5EF4-FFF2-40B4-BE49-F238E27FC236}">
-                <a16:creationId xmlns:a16="http://schemas.microsoft.com/office/drawing/2014/main" id="{0E3FCBD2-E118-EA76-2277-324B77D22978}"/>
+                <a16:creationId xmlns:a16="http://schemas.microsoft.com/office/drawing/2014/main" id="{3821A51B-FD00-A922-9332-D7F2DFFF4ABD}"/>
               </a:ext>
             </a:extLst>
           </p:cNvPr>
@@ -2583,7 +2581,7 @@
           <p:cNvPr id="4" name="Text Placeholder 3">
             <a:extLst>
               <a:ext uri="{FF2B5EF4-FFF2-40B4-BE49-F238E27FC236}">
-                <a16:creationId xmlns:a16="http://schemas.microsoft.com/office/drawing/2014/main" id="{05D57096-CAE5-5B9E-19B3-90D8C07E77C5}"/>
+                <a16:creationId xmlns:a16="http://schemas.microsoft.com/office/drawing/2014/main" id="{75A4C8E1-45CE-2C73-B4E3-2441F952151B}"/>
               </a:ext>
             </a:extLst>
           </p:cNvPr>
@@ -2654,7 +2652,7 @@
           <p:cNvPr id="5" name="Date Placeholder 4">
             <a:extLst>
               <a:ext uri="{FF2B5EF4-FFF2-40B4-BE49-F238E27FC236}">
-                <a16:creationId xmlns:a16="http://schemas.microsoft.com/office/drawing/2014/main" id="{AD87CFAF-DFED-9FD7-2DF4-7B40E68A3B4A}"/>
+                <a16:creationId xmlns:a16="http://schemas.microsoft.com/office/drawing/2014/main" id="{2A877784-C85A-99E7-91EE-34B249B3B273}"/>
               </a:ext>
             </a:extLst>
           </p:cNvPr>
@@ -2683,7 +2681,7 @@
           <p:cNvPr id="6" name="Footer Placeholder 5">
             <a:extLst>
               <a:ext uri="{FF2B5EF4-FFF2-40B4-BE49-F238E27FC236}">
-                <a16:creationId xmlns:a16="http://schemas.microsoft.com/office/drawing/2014/main" id="{1C904A62-B86E-95BA-B05A-8456F543C39B}"/>
+                <a16:creationId xmlns:a16="http://schemas.microsoft.com/office/drawing/2014/main" id="{EF463E5B-7447-7387-3B54-D57786C6BFBB}"/>
               </a:ext>
             </a:extLst>
           </p:cNvPr>
@@ -2708,7 +2706,7 @@
           <p:cNvPr id="7" name="Slide Number Placeholder 6">
             <a:extLst>
               <a:ext uri="{FF2B5EF4-FFF2-40B4-BE49-F238E27FC236}">
-                <a16:creationId xmlns:a16="http://schemas.microsoft.com/office/drawing/2014/main" id="{A83F8564-6C62-FC79-0111-E1D005F9937F}"/>
+                <a16:creationId xmlns:a16="http://schemas.microsoft.com/office/drawing/2014/main" id="{EB19B437-DCB9-3A57-1E22-84EE1D3C1F48}"/>
               </a:ext>
             </a:extLst>
           </p:cNvPr>
@@ -2735,7 +2733,7 @@
     </p:spTree>
     <p:extLst>
       <p:ext uri="{BB962C8B-B14F-4D97-AF65-F5344CB8AC3E}">
-        <p14:creationId xmlns:p14="http://schemas.microsoft.com/office/powerpoint/2010/main" val="4148086408"/>
+        <p14:creationId xmlns:p14="http://schemas.microsoft.com/office/powerpoint/2010/main" val="1575784484"/>
       </p:ext>
     </p:extLst>
   </p:cSld>
@@ -2772,7 +2770,7 @@
           <p:cNvPr id="2" name="Title Placeholder 1">
             <a:extLst>
               <a:ext uri="{FF2B5EF4-FFF2-40B4-BE49-F238E27FC236}">
-                <a16:creationId xmlns:a16="http://schemas.microsoft.com/office/drawing/2014/main" id="{1C5D8088-8CC3-79C0-A956-4BD7418EEAE5}"/>
+                <a16:creationId xmlns:a16="http://schemas.microsoft.com/office/drawing/2014/main" id="{F646B66B-8D7F-C18D-9D2E-2275314D6C6B}"/>
               </a:ext>
             </a:extLst>
           </p:cNvPr>
@@ -2810,7 +2808,7 @@
           <p:cNvPr id="3" name="Text Placeholder 2">
             <a:extLst>
               <a:ext uri="{FF2B5EF4-FFF2-40B4-BE49-F238E27FC236}">
-                <a16:creationId xmlns:a16="http://schemas.microsoft.com/office/drawing/2014/main" id="{93603C9A-318F-302F-52C4-3CA917864E78}"/>
+                <a16:creationId xmlns:a16="http://schemas.microsoft.com/office/drawing/2014/main" id="{9CCB5840-EE07-D558-CD72-5619ADAF3117}"/>
               </a:ext>
             </a:extLst>
           </p:cNvPr>
@@ -2877,7 +2875,7 @@
           <p:cNvPr id="4" name="Date Placeholder 3">
             <a:extLst>
               <a:ext uri="{FF2B5EF4-FFF2-40B4-BE49-F238E27FC236}">
-                <a16:creationId xmlns:a16="http://schemas.microsoft.com/office/drawing/2014/main" id="{DCCC23E4-6224-BDBD-3FBF-633E8FC49116}"/>
+                <a16:creationId xmlns:a16="http://schemas.microsoft.com/office/drawing/2014/main" id="{73848462-3DF5-B642-D002-A2F4A089CD83}"/>
               </a:ext>
             </a:extLst>
           </p:cNvPr>
@@ -2924,7 +2922,7 @@
           <p:cNvPr id="5" name="Footer Placeholder 4">
             <a:extLst>
               <a:ext uri="{FF2B5EF4-FFF2-40B4-BE49-F238E27FC236}">
-                <a16:creationId xmlns:a16="http://schemas.microsoft.com/office/drawing/2014/main" id="{F4DC4C1A-C4FD-17DF-0D0F-A58C786ED636}"/>
+                <a16:creationId xmlns:a16="http://schemas.microsoft.com/office/drawing/2014/main" id="{0B2A783C-1B50-F884-1F29-9A7F6C9EBCAB}"/>
               </a:ext>
             </a:extLst>
           </p:cNvPr>
@@ -2967,7 +2965,7 @@
           <p:cNvPr id="6" name="Slide Number Placeholder 5">
             <a:extLst>
               <a:ext uri="{FF2B5EF4-FFF2-40B4-BE49-F238E27FC236}">
-                <a16:creationId xmlns:a16="http://schemas.microsoft.com/office/drawing/2014/main" id="{30D7B9A6-C9CC-124B-5370-A0FB97C3DA33}"/>
+                <a16:creationId xmlns:a16="http://schemas.microsoft.com/office/drawing/2014/main" id="{8E8DA988-1717-E388-53D9-61AC1BAEFA11}"/>
               </a:ext>
             </a:extLst>
           </p:cNvPr>
@@ -3012,23 +3010,23 @@
     </p:spTree>
     <p:extLst>
       <p:ext uri="{BB962C8B-B14F-4D97-AF65-F5344CB8AC3E}">
-        <p14:creationId xmlns:p14="http://schemas.microsoft.com/office/powerpoint/2010/main" val="3916788838"/>
+        <p14:creationId xmlns:p14="http://schemas.microsoft.com/office/powerpoint/2010/main" val="3049262780"/>
       </p:ext>
     </p:extLst>
   </p:cSld>
   <p:clrMap bg1="lt1" tx1="dk1" bg2="lt2" tx2="dk2" accent1="accent1" accent2="accent2" accent3="accent3" accent4="accent4" accent5="accent5" accent6="accent6" hlink="hlink" folHlink="folHlink"/>
   <p:sldLayoutIdLst>
-    <p:sldLayoutId id="2147483649" r:id="rId1"/>
-    <p:sldLayoutId id="2147483650" r:id="rId2"/>
-    <p:sldLayoutId id="2147483651" r:id="rId3"/>
-    <p:sldLayoutId id="2147483652" r:id="rId4"/>
-    <p:sldLayoutId id="2147483653" r:id="rId5"/>
-    <p:sldLayoutId id="2147483654" r:id="rId6"/>
-    <p:sldLayoutId id="2147483655" r:id="rId7"/>
-    <p:sldLayoutId id="2147483656" r:id="rId8"/>
-    <p:sldLayoutId id="2147483657" r:id="rId9"/>
-    <p:sldLayoutId id="2147483658" r:id="rId10"/>
-    <p:sldLayoutId id="2147483659" r:id="rId11"/>
+    <p:sldLayoutId id="2147483690" r:id="rId1"/>
+    <p:sldLayoutId id="2147483691" r:id="rId2"/>
+    <p:sldLayoutId id="2147483692" r:id="rId3"/>
+    <p:sldLayoutId id="2147483693" r:id="rId4"/>
+    <p:sldLayoutId id="2147483694" r:id="rId5"/>
+    <p:sldLayoutId id="2147483695" r:id="rId6"/>
+    <p:sldLayoutId id="2147483696" r:id="rId7"/>
+    <p:sldLayoutId id="2147483697" r:id="rId8"/>
+    <p:sldLayoutId id="2147483698" r:id="rId9"/>
+    <p:sldLayoutId id="2147483699" r:id="rId10"/>
+    <p:sldLayoutId id="2147483700" r:id="rId11"/>
   </p:sldLayoutIdLst>
   <p:txStyles>
     <p:titleStyle>
@@ -3401,90 +3399,6 @@
 </p:sld>
 </file>
 
-<file path=ppt/slides/slide10.xml><?xml version="1.0" encoding="utf-8"?>
-<p:sld xmlns:a="http://schemas.openxmlformats.org/drawingml/2006/main" xmlns:r="http://schemas.openxmlformats.org/officeDocument/2006/relationships" xmlns:p="http://schemas.openxmlformats.org/presentationml/2006/main">
-  <p:cSld>
-    <p:spTree>
-      <p:nvGrpSpPr>
-        <p:cNvPr id="1" name=""/>
-        <p:cNvGrpSpPr/>
-        <p:nvPr/>
-      </p:nvGrpSpPr>
-      <p:grpSpPr>
-        <a:xfrm>
-          <a:off x="0" y="0"/>
-          <a:ext cx="0" cy="0"/>
-          <a:chOff x="0" y="0"/>
-          <a:chExt cx="0" cy="0"/>
-        </a:xfrm>
-      </p:grpSpPr>
-      <p:sp>
-        <p:nvSpPr>
-          <p:cNvPr id="2" name="Title 1">
-            <a:extLst>
-              <a:ext uri="{FF2B5EF4-FFF2-40B4-BE49-F238E27FC236}">
-                <a16:creationId xmlns:a16="http://schemas.microsoft.com/office/drawing/2014/main" id="{4BCC6D43-864B-597A-06E7-F4CB27DEB6B9}"/>
-              </a:ext>
-            </a:extLst>
-          </p:cNvPr>
-          <p:cNvSpPr>
-            <a:spLocks noGrp="1"/>
-          </p:cNvSpPr>
-          <p:nvPr>
-            <p:ph type="title"/>
-          </p:nvPr>
-        </p:nvSpPr>
-        <p:spPr/>
-        <p:txBody>
-          <a:bodyPr/>
-          <a:lstStyle/>
-          <a:p>
-            <a:r>
-              <a:rPr lang="en-US"/>
-              <a:t>References</a:t>
-            </a:r>
-            <a:endParaRPr lang="en-US" dirty="0"/>
-          </a:p>
-        </p:txBody>
-      </p:sp>
-      <p:sp>
-        <p:nvSpPr>
-          <p:cNvPr id="3" name="Content Placeholder 2">
-            <a:extLst>
-              <a:ext uri="{FF2B5EF4-FFF2-40B4-BE49-F238E27FC236}">
-                <a16:creationId xmlns:a16="http://schemas.microsoft.com/office/drawing/2014/main" id="{FD2F129D-B2DA-EA8B-0C9F-41CB9EA9FB72}"/>
-              </a:ext>
-            </a:extLst>
-          </p:cNvPr>
-          <p:cNvSpPr>
-            <a:spLocks noGrp="1"/>
-          </p:cNvSpPr>
-          <p:nvPr>
-            <p:ph idx="1"/>
-          </p:nvPr>
-        </p:nvSpPr>
-        <p:spPr/>
-        <p:txBody>
-          <a:bodyPr/>
-          <a:lstStyle/>
-          <a:p>
-            <a:endParaRPr lang="en-US"/>
-          </a:p>
-        </p:txBody>
-      </p:sp>
-    </p:spTree>
-    <p:extLst>
-      <p:ext uri="{BB962C8B-B14F-4D97-AF65-F5344CB8AC3E}">
-        <p14:creationId xmlns:p14="http://schemas.microsoft.com/office/powerpoint/2010/main" val="867442417"/>
-      </p:ext>
-    </p:extLst>
-  </p:cSld>
-  <p:clrMapOvr>
-    <a:masterClrMapping/>
-  </p:clrMapOvr>
-</p:sld>
-</file>
-
 <file path=ppt/slides/slide2.xml><?xml version="1.0" encoding="utf-8"?>
 <p:sld xmlns:a="http://schemas.openxmlformats.org/drawingml/2006/main" xmlns:r="http://schemas.openxmlformats.org/officeDocument/2006/relationships" xmlns:p="http://schemas.openxmlformats.org/presentationml/2006/main">
   <p:cSld>
@@ -3551,7 +3465,57 @@
           <a:bodyPr/>
           <a:lstStyle/>
           <a:p>
-            <a:endParaRPr lang="en-US"/>
+            <a:r>
+              <a:rPr lang="en-US" dirty="0"/>
+              <a:t>Knee osteoarthritis is a very common degenerative joint disease</a:t>
+            </a:r>
+          </a:p>
+          <a:p>
+            <a:pPr lvl="1"/>
+            <a:r>
+              <a:rPr lang="en-US" dirty="0"/>
+              <a:t>Pain, swelling, stiffness</a:t>
+            </a:r>
+          </a:p>
+          <a:p>
+            <a:r>
+              <a:rPr lang="en-US" dirty="0"/>
+              <a:t>Affects roughly 23% of adults over 40 worldwide</a:t>
+            </a:r>
+          </a:p>
+          <a:p>
+            <a:pPr lvl="1"/>
+            <a:r>
+              <a:rPr lang="en-US" dirty="0"/>
+              <a:t>365 million people</a:t>
+            </a:r>
+          </a:p>
+          <a:p>
+            <a:r>
+              <a:rPr lang="en-US" dirty="0"/>
+              <a:t>Medical Professionals are busy!!!</a:t>
+            </a:r>
+          </a:p>
+          <a:p>
+            <a:pPr lvl="1"/>
+            <a:r>
+              <a:rPr lang="en-US" dirty="0"/>
+              <a:t>Too many patients, not enough doctors</a:t>
+            </a:r>
+          </a:p>
+          <a:p>
+            <a:pPr lvl="1"/>
+            <a:r>
+              <a:rPr lang="en-US" dirty="0"/>
+              <a:t>Diagnostics done with imaging (radiographs) can be aided easily by AI tools</a:t>
+            </a:r>
+          </a:p>
+          <a:p>
+            <a:pPr lvl="2"/>
+            <a:r>
+              <a:rPr lang="en-US" dirty="0"/>
+              <a:t>Save medical professional’s time</a:t>
+            </a:r>
           </a:p>
         </p:txBody>
       </p:sp>
@@ -3613,31 +3577,42 @@
           </a:p>
         </p:txBody>
       </p:sp>
-      <p:sp>
-        <p:nvSpPr>
-          <p:cNvPr id="3" name="Content Placeholder 2">
-            <a:extLst>
-              <a:ext uri="{FF2B5EF4-FFF2-40B4-BE49-F238E27FC236}">
-                <a16:creationId xmlns:a16="http://schemas.microsoft.com/office/drawing/2014/main" id="{D1FCBE35-CACC-4E42-0434-9D592CE9DC2C}"/>
-              </a:ext>
-            </a:extLst>
-          </p:cNvPr>
-          <p:cNvSpPr>
-            <a:spLocks noGrp="1"/>
-          </p:cNvSpPr>
-          <p:nvPr>
-            <p:ph idx="1"/>
-          </p:nvPr>
-        </p:nvSpPr>
-        <p:spPr/>
-        <p:txBody>
-          <a:bodyPr/>
-          <a:lstStyle/>
-          <a:p>
-            <a:endParaRPr lang="en-US"/>
-          </a:p>
-        </p:txBody>
-      </p:sp>
+      <p:pic>
+        <p:nvPicPr>
+          <p:cNvPr id="4" name="Picture 3">
+            <a:extLst>
+              <a:ext uri="{FF2B5EF4-FFF2-40B4-BE49-F238E27FC236}">
+                <a16:creationId xmlns:a16="http://schemas.microsoft.com/office/drawing/2014/main" id="{A3957F1D-CBF3-2862-FD0E-833262530C78}"/>
+              </a:ext>
+            </a:extLst>
+          </p:cNvPr>
+          <p:cNvPicPr>
+            <a:picLocks noChangeAspect="1"/>
+          </p:cNvPicPr>
+          <p:nvPr/>
+        </p:nvPicPr>
+        <p:blipFill>
+          <a:blip r:embed="rId2" cstate="print">
+            <a:extLst>
+              <a:ext uri="{28A0092B-C50C-407E-A947-70E740481C1C}">
+                <a14:useLocalDpi xmlns:a14="http://schemas.microsoft.com/office/drawing/2010/main" val="0"/>
+              </a:ext>
+            </a:extLst>
+          </a:blip>
+          <a:stretch>
+            <a:fillRect/>
+          </a:stretch>
+        </p:blipFill>
+        <p:spPr>
+          <a:xfrm>
+            <a:off x="274734" y="1690688"/>
+            <a:ext cx="11642532" cy="3571123"/>
+          </a:xfrm>
+          <a:prstGeom prst="rect">
+            <a:avLst/>
+          </a:prstGeom>
+        </p:spPr>
+      </p:pic>
     </p:spTree>
     <p:extLst>
       <p:ext uri="{BB962C8B-B14F-4D97-AF65-F5344CB8AC3E}">
@@ -3691,7 +3666,7 @@
           <a:p>
             <a:r>
               <a:rPr lang="en-US" dirty="0"/>
-              <a:t>Evaluation setup</a:t>
+              <a:t>Experimental Setup</a:t>
             </a:r>
           </a:p>
         </p:txBody>
@@ -3712,12 +3687,68 @@
             <p:ph idx="1"/>
           </p:nvPr>
         </p:nvSpPr>
-        <p:spPr/>
-        <p:txBody>
-          <a:bodyPr/>
-          <a:lstStyle/>
-          <a:p>
-            <a:endParaRPr lang="en-US"/>
+        <p:spPr>
+          <a:xfrm>
+            <a:off x="838200" y="1363579"/>
+            <a:ext cx="10515600" cy="5129296"/>
+          </a:xfrm>
+        </p:spPr>
+        <p:txBody>
+          <a:bodyPr>
+            <a:normAutofit/>
+          </a:bodyPr>
+          <a:lstStyle/>
+          <a:p>
+            <a:r>
+              <a:rPr lang="en-US" dirty="0"/>
+              <a:t>Ran on CUDA on personal PC</a:t>
+            </a:r>
+          </a:p>
+          <a:p>
+            <a:r>
+              <a:rPr lang="en-US" dirty="0"/>
+              <a:t>Cross Entropy Loss Function</a:t>
+            </a:r>
+          </a:p>
+          <a:p>
+            <a:r>
+              <a:rPr lang="en-US" dirty="0"/>
+              <a:t>Optimized with Adam</a:t>
+            </a:r>
+          </a:p>
+          <a:p>
+            <a:r>
+              <a:rPr lang="en-US" dirty="0"/>
+              <a:t>For both frozen, and finetuning: found best learning rate</a:t>
+            </a:r>
+          </a:p>
+          <a:p>
+            <a:pPr lvl="1"/>
+            <a:r>
+              <a:rPr lang="en-US" dirty="0"/>
+              <a:t>15 epochs, from 1e-1 to 1e-7 by steps of 0.1</a:t>
+            </a:r>
+          </a:p>
+          <a:p>
+            <a:pPr lvl="1"/>
+            <a:r>
+              <a:rPr lang="en-US" dirty="0"/>
+              <a:t>Used 70% training, 15% validation, 15% evaluation</a:t>
+            </a:r>
+          </a:p>
+          <a:p>
+            <a:pPr lvl="1"/>
+            <a:r>
+              <a:rPr lang="en-US" dirty="0"/>
+              <a:t>Found 1e-6 was best for frozen, 1e-5 best for finetuning</a:t>
+            </a:r>
+          </a:p>
+          <a:p>
+            <a:pPr lvl="2"/>
+            <a:r>
+              <a:rPr lang="en-US" dirty="0"/>
+              <a:t>Full table on paper, not super important to showcase</a:t>
+            </a:r>
           </a:p>
         </p:txBody>
       </p:sp>
@@ -3756,7 +3787,7 @@
           <p:cNvPr id="2" name="Title 1">
             <a:extLst>
               <a:ext uri="{FF2B5EF4-FFF2-40B4-BE49-F238E27FC236}">
-                <a16:creationId xmlns:a16="http://schemas.microsoft.com/office/drawing/2014/main" id="{ECCBE784-DC41-CA0A-0EB0-F8D38A701EFD}"/>
+                <a16:creationId xmlns:a16="http://schemas.microsoft.com/office/drawing/2014/main" id="{274E8752-98CF-FE63-BC8D-36F16B29DA93}"/>
               </a:ext>
             </a:extLst>
           </p:cNvPr>
@@ -3774,40 +3805,64 @@
           <a:p>
             <a:r>
               <a:rPr lang="en-US" dirty="0"/>
-              <a:t>Finding best learning rate</a:t>
-            </a:r>
-          </a:p>
-        </p:txBody>
-      </p:sp>
-      <p:sp>
-        <p:nvSpPr>
-          <p:cNvPr id="3" name="Content Placeholder 2">
-            <a:extLst>
-              <a:ext uri="{FF2B5EF4-FFF2-40B4-BE49-F238E27FC236}">
-                <a16:creationId xmlns:a16="http://schemas.microsoft.com/office/drawing/2014/main" id="{C7520FA5-11B5-2D1B-E4B2-5B9E6D2BA992}"/>
-              </a:ext>
-            </a:extLst>
-          </p:cNvPr>
-          <p:cNvSpPr>
-            <a:spLocks noGrp="1"/>
-          </p:cNvSpPr>
-          <p:nvPr>
-            <p:ph idx="1"/>
-          </p:nvPr>
-        </p:nvSpPr>
-        <p:spPr/>
-        <p:txBody>
-          <a:bodyPr/>
-          <a:lstStyle/>
-          <a:p>
-            <a:endParaRPr lang="en-US"/>
+              <a:t>Results – Changes on amount of training data</a:t>
+            </a:r>
+          </a:p>
+        </p:txBody>
+      </p:sp>
+      <p:sp>
+        <p:nvSpPr>
+          <p:cNvPr id="4" name="Rectangle 3">
+            <a:extLst>
+              <a:ext uri="{FF2B5EF4-FFF2-40B4-BE49-F238E27FC236}">
+                <a16:creationId xmlns:a16="http://schemas.microsoft.com/office/drawing/2014/main" id="{88F2F122-2BFD-59B7-72C4-A93164BEC4EF}"/>
+              </a:ext>
+            </a:extLst>
+          </p:cNvPr>
+          <p:cNvSpPr/>
+          <p:nvPr/>
+        </p:nvSpPr>
+        <p:spPr>
+          <a:xfrm>
+            <a:off x="838200" y="1690688"/>
+            <a:ext cx="10311063" cy="4437396"/>
+          </a:xfrm>
+          <a:prstGeom prst="rect">
+            <a:avLst/>
+          </a:prstGeom>
+        </p:spPr>
+        <p:style>
+          <a:lnRef idx="2">
+            <a:schemeClr val="accent1">
+              <a:shade val="15000"/>
+            </a:schemeClr>
+          </a:lnRef>
+          <a:fillRef idx="1">
+            <a:schemeClr val="accent1"/>
+          </a:fillRef>
+          <a:effectRef idx="0">
+            <a:schemeClr val="accent1"/>
+          </a:effectRef>
+          <a:fontRef idx="minor">
+            <a:schemeClr val="lt1"/>
+          </a:fontRef>
+        </p:style>
+        <p:txBody>
+          <a:bodyPr rtlCol="0" anchor="ctr"/>
+          <a:lstStyle/>
+          <a:p>
+            <a:pPr algn="ctr"/>
+            <a:r>
+              <a:rPr lang="en-US" dirty="0"/>
+              <a:t>&lt;table2&gt;</a:t>
+            </a:r>
           </a:p>
         </p:txBody>
       </p:sp>
     </p:spTree>
     <p:extLst>
       <p:ext uri="{BB962C8B-B14F-4D97-AF65-F5344CB8AC3E}">
-        <p14:creationId xmlns:p14="http://schemas.microsoft.com/office/powerpoint/2010/main" val="2486078367"/>
+        <p14:creationId xmlns:p14="http://schemas.microsoft.com/office/powerpoint/2010/main" val="4292682272"/>
       </p:ext>
     </p:extLst>
   </p:cSld>
@@ -3822,7 +3877,13 @@
   <p:cSld>
     <p:spTree>
       <p:nvGrpSpPr>
-        <p:cNvPr id="1" name=""/>
+        <p:cNvPr id="1" name="">
+          <a:extLst>
+            <a:ext uri="{FF2B5EF4-FFF2-40B4-BE49-F238E27FC236}">
+              <a16:creationId xmlns:a16="http://schemas.microsoft.com/office/drawing/2014/main" id="{50123067-D7DA-4869-F4A5-607CE8A9C521}"/>
+            </a:ext>
+          </a:extLst>
+        </p:cNvPr>
         <p:cNvGrpSpPr/>
         <p:nvPr/>
       </p:nvGrpSpPr>
@@ -3839,7 +3900,7 @@
           <p:cNvPr id="2" name="Title 1">
             <a:extLst>
               <a:ext uri="{FF2B5EF4-FFF2-40B4-BE49-F238E27FC236}">
-                <a16:creationId xmlns:a16="http://schemas.microsoft.com/office/drawing/2014/main" id="{274E8752-98CF-FE63-BC8D-36F16B29DA93}"/>
+                <a16:creationId xmlns:a16="http://schemas.microsoft.com/office/drawing/2014/main" id="{289342E6-B797-DE94-4962-E2AEA991EC01}"/>
               </a:ext>
             </a:extLst>
           </p:cNvPr>
@@ -3857,40 +3918,302 @@
           <a:p>
             <a:r>
               <a:rPr lang="en-US" dirty="0"/>
-              <a:t>Results – Frozen DinoV2</a:t>
-            </a:r>
-          </a:p>
-        </p:txBody>
-      </p:sp>
-      <p:sp>
-        <p:nvSpPr>
-          <p:cNvPr id="3" name="Content Placeholder 2">
-            <a:extLst>
-              <a:ext uri="{FF2B5EF4-FFF2-40B4-BE49-F238E27FC236}">
-                <a16:creationId xmlns:a16="http://schemas.microsoft.com/office/drawing/2014/main" id="{078ACEA1-EFB5-2499-8816-3A9FA5F68626}"/>
-              </a:ext>
-            </a:extLst>
-          </p:cNvPr>
-          <p:cNvSpPr>
-            <a:spLocks noGrp="1"/>
-          </p:cNvSpPr>
-          <p:nvPr>
-            <p:ph idx="1"/>
-          </p:nvPr>
-        </p:nvSpPr>
-        <p:spPr/>
-        <p:txBody>
-          <a:bodyPr/>
-          <a:lstStyle/>
-          <a:p>
-            <a:endParaRPr lang="en-US"/>
+              <a:t>Results – Frozen DinoV2 vs Finetuning</a:t>
+            </a:r>
+          </a:p>
+        </p:txBody>
+      </p:sp>
+      <p:sp>
+        <p:nvSpPr>
+          <p:cNvPr id="4" name="Rectangle 3">
+            <a:extLst>
+              <a:ext uri="{FF2B5EF4-FFF2-40B4-BE49-F238E27FC236}">
+                <a16:creationId xmlns:a16="http://schemas.microsoft.com/office/drawing/2014/main" id="{6B897169-BAC4-4207-00CD-61A102AA5EAF}"/>
+              </a:ext>
+            </a:extLst>
+          </p:cNvPr>
+          <p:cNvSpPr/>
+          <p:nvPr/>
+        </p:nvSpPr>
+        <p:spPr>
+          <a:xfrm>
+            <a:off x="838200" y="1690688"/>
+            <a:ext cx="6878053" cy="1738312"/>
+          </a:xfrm>
+          <a:prstGeom prst="rect">
+            <a:avLst/>
+          </a:prstGeom>
+        </p:spPr>
+        <p:style>
+          <a:lnRef idx="2">
+            <a:schemeClr val="accent1">
+              <a:shade val="15000"/>
+            </a:schemeClr>
+          </a:lnRef>
+          <a:fillRef idx="1">
+            <a:schemeClr val="accent1"/>
+          </a:fillRef>
+          <a:effectRef idx="0">
+            <a:schemeClr val="accent1"/>
+          </a:effectRef>
+          <a:fontRef idx="minor">
+            <a:schemeClr val="lt1"/>
+          </a:fontRef>
+        </p:style>
+        <p:txBody>
+          <a:bodyPr rtlCol="0" anchor="ctr"/>
+          <a:lstStyle/>
+          <a:p>
+            <a:pPr algn="ctr"/>
+            <a:r>
+              <a:rPr lang="en-US" dirty="0"/>
+              <a:t>Small table</a:t>
+            </a:r>
+          </a:p>
+          <a:p>
+            <a:pPr algn="ctr"/>
+            <a:r>
+              <a:rPr lang="en-US" dirty="0"/>
+              <a:t>&lt;best of Frozen&gt;</a:t>
+            </a:r>
+          </a:p>
+          <a:p>
+            <a:pPr algn="ctr"/>
+            <a:r>
+              <a:rPr lang="en-US" dirty="0"/>
+              <a:t>&lt;best of finetuning&gt;</a:t>
+            </a:r>
+          </a:p>
+        </p:txBody>
+      </p:sp>
+      <p:sp>
+        <p:nvSpPr>
+          <p:cNvPr id="3" name="Rectangle 2">
+            <a:extLst>
+              <a:ext uri="{FF2B5EF4-FFF2-40B4-BE49-F238E27FC236}">
+                <a16:creationId xmlns:a16="http://schemas.microsoft.com/office/drawing/2014/main" id="{4962C47D-079E-5A3D-E64B-347C273C0246}"/>
+              </a:ext>
+            </a:extLst>
+          </p:cNvPr>
+          <p:cNvSpPr/>
+          <p:nvPr/>
+        </p:nvSpPr>
+        <p:spPr>
+          <a:xfrm>
+            <a:off x="838200" y="4298156"/>
+            <a:ext cx="2346158" cy="1738312"/>
+          </a:xfrm>
+          <a:prstGeom prst="rect">
+            <a:avLst/>
+          </a:prstGeom>
+        </p:spPr>
+        <p:style>
+          <a:lnRef idx="2">
+            <a:schemeClr val="accent1">
+              <a:shade val="15000"/>
+            </a:schemeClr>
+          </a:lnRef>
+          <a:fillRef idx="1">
+            <a:schemeClr val="accent1"/>
+          </a:fillRef>
+          <a:effectRef idx="0">
+            <a:schemeClr val="accent1"/>
+          </a:effectRef>
+          <a:fontRef idx="minor">
+            <a:schemeClr val="lt1"/>
+          </a:fontRef>
+        </p:style>
+        <p:txBody>
+          <a:bodyPr rtlCol="0" anchor="ctr"/>
+          <a:lstStyle/>
+          <a:p>
+            <a:pPr algn="ctr"/>
+            <a:r>
+              <a:rPr lang="en-US" dirty="0"/>
+              <a:t>Confusion Matrix</a:t>
+            </a:r>
+          </a:p>
+          <a:p>
+            <a:pPr algn="ctr"/>
+            <a:r>
+              <a:rPr lang="en-US" dirty="0"/>
+              <a:t>&lt;best of frozen&gt;</a:t>
+            </a:r>
+          </a:p>
+        </p:txBody>
+      </p:sp>
+      <p:sp>
+        <p:nvSpPr>
+          <p:cNvPr id="5" name="Rectangle 4">
+            <a:extLst>
+              <a:ext uri="{FF2B5EF4-FFF2-40B4-BE49-F238E27FC236}">
+                <a16:creationId xmlns:a16="http://schemas.microsoft.com/office/drawing/2014/main" id="{68DCBE69-1410-AE82-63D2-54725C72575E}"/>
+              </a:ext>
+            </a:extLst>
+          </p:cNvPr>
+          <p:cNvSpPr/>
+          <p:nvPr/>
+        </p:nvSpPr>
+        <p:spPr>
+          <a:xfrm>
+            <a:off x="3402930" y="4298156"/>
+            <a:ext cx="2346158" cy="1738312"/>
+          </a:xfrm>
+          <a:prstGeom prst="rect">
+            <a:avLst/>
+          </a:prstGeom>
+        </p:spPr>
+        <p:style>
+          <a:lnRef idx="2">
+            <a:schemeClr val="accent1">
+              <a:shade val="15000"/>
+            </a:schemeClr>
+          </a:lnRef>
+          <a:fillRef idx="1">
+            <a:schemeClr val="accent1"/>
+          </a:fillRef>
+          <a:effectRef idx="0">
+            <a:schemeClr val="accent1"/>
+          </a:effectRef>
+          <a:fontRef idx="minor">
+            <a:schemeClr val="lt1"/>
+          </a:fontRef>
+        </p:style>
+        <p:txBody>
+          <a:bodyPr rtlCol="0" anchor="ctr"/>
+          <a:lstStyle/>
+          <a:p>
+            <a:pPr algn="ctr"/>
+            <a:r>
+              <a:rPr lang="en-US" dirty="0"/>
+              <a:t>ROC Curve</a:t>
+            </a:r>
+          </a:p>
+          <a:p>
+            <a:pPr algn="ctr"/>
+            <a:r>
+              <a:rPr lang="en-US" dirty="0"/>
+              <a:t>&lt;best of frozen&gt;</a:t>
+            </a:r>
+          </a:p>
+        </p:txBody>
+      </p:sp>
+      <p:sp>
+        <p:nvSpPr>
+          <p:cNvPr id="6" name="Rectangle 5">
+            <a:extLst>
+              <a:ext uri="{FF2B5EF4-FFF2-40B4-BE49-F238E27FC236}">
+                <a16:creationId xmlns:a16="http://schemas.microsoft.com/office/drawing/2014/main" id="{733B41EB-EF63-9BEB-6175-4B8631388830}"/>
+              </a:ext>
+            </a:extLst>
+          </p:cNvPr>
+          <p:cNvSpPr/>
+          <p:nvPr/>
+        </p:nvSpPr>
+        <p:spPr>
+          <a:xfrm>
+            <a:off x="6821903" y="4298156"/>
+            <a:ext cx="2346158" cy="1738312"/>
+          </a:xfrm>
+          <a:prstGeom prst="rect">
+            <a:avLst/>
+          </a:prstGeom>
+        </p:spPr>
+        <p:style>
+          <a:lnRef idx="2">
+            <a:schemeClr val="accent1">
+              <a:shade val="15000"/>
+            </a:schemeClr>
+          </a:lnRef>
+          <a:fillRef idx="1">
+            <a:schemeClr val="accent1"/>
+          </a:fillRef>
+          <a:effectRef idx="0">
+            <a:schemeClr val="accent1"/>
+          </a:effectRef>
+          <a:fontRef idx="minor">
+            <a:schemeClr val="lt1"/>
+          </a:fontRef>
+        </p:style>
+        <p:txBody>
+          <a:bodyPr rtlCol="0" anchor="ctr"/>
+          <a:lstStyle/>
+          <a:p>
+            <a:pPr algn="ctr"/>
+            <a:r>
+              <a:rPr lang="en-US" dirty="0"/>
+              <a:t>Confusion Matrix</a:t>
+            </a:r>
+          </a:p>
+          <a:p>
+            <a:pPr algn="ctr"/>
+            <a:r>
+              <a:rPr lang="en-US" dirty="0"/>
+              <a:t>&lt;best of finetuning&gt;</a:t>
+            </a:r>
+          </a:p>
+        </p:txBody>
+      </p:sp>
+      <p:sp>
+        <p:nvSpPr>
+          <p:cNvPr id="7" name="Rectangle 6">
+            <a:extLst>
+              <a:ext uri="{FF2B5EF4-FFF2-40B4-BE49-F238E27FC236}">
+                <a16:creationId xmlns:a16="http://schemas.microsoft.com/office/drawing/2014/main" id="{D58A6A66-DD34-2493-A522-545389E3E5A8}"/>
+              </a:ext>
+            </a:extLst>
+          </p:cNvPr>
+          <p:cNvSpPr/>
+          <p:nvPr/>
+        </p:nvSpPr>
+        <p:spPr>
+          <a:xfrm>
+            <a:off x="9386633" y="4298156"/>
+            <a:ext cx="2346158" cy="1738312"/>
+          </a:xfrm>
+          <a:prstGeom prst="rect">
+            <a:avLst/>
+          </a:prstGeom>
+        </p:spPr>
+        <p:style>
+          <a:lnRef idx="2">
+            <a:schemeClr val="accent1">
+              <a:shade val="15000"/>
+            </a:schemeClr>
+          </a:lnRef>
+          <a:fillRef idx="1">
+            <a:schemeClr val="accent1"/>
+          </a:fillRef>
+          <a:effectRef idx="0">
+            <a:schemeClr val="accent1"/>
+          </a:effectRef>
+          <a:fontRef idx="minor">
+            <a:schemeClr val="lt1"/>
+          </a:fontRef>
+        </p:style>
+        <p:txBody>
+          <a:bodyPr rtlCol="0" anchor="ctr"/>
+          <a:lstStyle/>
+          <a:p>
+            <a:pPr algn="ctr"/>
+            <a:r>
+              <a:rPr lang="en-US" dirty="0"/>
+              <a:t>ROC Curve</a:t>
+            </a:r>
+          </a:p>
+          <a:p>
+            <a:pPr algn="ctr"/>
+            <a:r>
+              <a:rPr lang="en-US" dirty="0"/>
+              <a:t>&lt;best of finetuning&gt;</a:t>
+            </a:r>
           </a:p>
         </p:txBody>
       </p:sp>
     </p:spTree>
     <p:extLst>
       <p:ext uri="{BB962C8B-B14F-4D97-AF65-F5344CB8AC3E}">
-        <p14:creationId xmlns:p14="http://schemas.microsoft.com/office/powerpoint/2010/main" val="4292682272"/>
+        <p14:creationId xmlns:p14="http://schemas.microsoft.com/office/powerpoint/2010/main" val="2351910854"/>
       </p:ext>
     </p:extLst>
   </p:cSld>
@@ -3922,7 +4245,7 @@
           <p:cNvPr id="2" name="Title 1">
             <a:extLst>
               <a:ext uri="{FF2B5EF4-FFF2-40B4-BE49-F238E27FC236}">
-                <a16:creationId xmlns:a16="http://schemas.microsoft.com/office/drawing/2014/main" id="{3C455030-3BAB-6A93-6BE1-156A21694101}"/>
+                <a16:creationId xmlns:a16="http://schemas.microsoft.com/office/drawing/2014/main" id="{6372AEE6-241C-71A9-02E0-9F442F1F9841}"/>
               </a:ext>
             </a:extLst>
           </p:cNvPr>
@@ -3940,7 +4263,7 @@
           <a:p>
             <a:r>
               <a:rPr lang="en-US" dirty="0"/>
-              <a:t>Results - Finetuning</a:t>
+              <a:t>Discussion</a:t>
             </a:r>
           </a:p>
         </p:txBody>
@@ -3950,7 +4273,7 @@
           <p:cNvPr id="3" name="Content Placeholder 2">
             <a:extLst>
               <a:ext uri="{FF2B5EF4-FFF2-40B4-BE49-F238E27FC236}">
-                <a16:creationId xmlns:a16="http://schemas.microsoft.com/office/drawing/2014/main" id="{0DCCD1BC-99F1-F8FA-75E9-6927C6585810}"/>
+                <a16:creationId xmlns:a16="http://schemas.microsoft.com/office/drawing/2014/main" id="{1B05D83F-F5EE-C965-1C13-97A22F2866AB}"/>
               </a:ext>
             </a:extLst>
           </p:cNvPr>
@@ -3966,14 +4289,38 @@
           <a:bodyPr/>
           <a:lstStyle/>
           <a:p>
-            <a:endParaRPr lang="en-US"/>
+            <a:r>
+              <a:rPr lang="en-US" dirty="0"/>
+              <a:t>Evaluated likelihood of knee osteoarthritis in radiographs using DinoV2</a:t>
+            </a:r>
+          </a:p>
+          <a:p>
+            <a:pPr lvl="1"/>
+            <a:r>
+              <a:rPr lang="en-US" dirty="0"/>
+              <a:t>Captured changes in frozen vs finetuning backbone</a:t>
+            </a:r>
+          </a:p>
+          <a:p>
+            <a:pPr lvl="1"/>
+            <a:r>
+              <a:rPr lang="en-US" dirty="0"/>
+              <a:t>Captured how model performance increases with amount of data</a:t>
+            </a:r>
+          </a:p>
+          <a:p>
+            <a:pPr lvl="1"/>
+            <a:r>
+              <a:rPr lang="en-US" dirty="0"/>
+              <a:t>Obtained a model with a very high level of performance</a:t>
+            </a:r>
           </a:p>
         </p:txBody>
       </p:sp>
     </p:spTree>
     <p:extLst>
       <p:ext uri="{BB962C8B-B14F-4D97-AF65-F5344CB8AC3E}">
-        <p14:creationId xmlns:p14="http://schemas.microsoft.com/office/powerpoint/2010/main" val="2176867175"/>
+        <p14:creationId xmlns:p14="http://schemas.microsoft.com/office/powerpoint/2010/main" val="2542129820"/>
       </p:ext>
     </p:extLst>
   </p:cSld>
@@ -4005,7 +4352,7 @@
           <p:cNvPr id="2" name="Title 1">
             <a:extLst>
               <a:ext uri="{FF2B5EF4-FFF2-40B4-BE49-F238E27FC236}">
-                <a16:creationId xmlns:a16="http://schemas.microsoft.com/office/drawing/2014/main" id="{E034873D-B9F1-088B-1AA5-DC8A476BCFC9}"/>
+                <a16:creationId xmlns:a16="http://schemas.microsoft.com/office/drawing/2014/main" id="{4BCC6D43-864B-597A-06E7-F4CB27DEB6B9}"/>
               </a:ext>
             </a:extLst>
           </p:cNvPr>
@@ -4023,7 +4370,7 @@
           <a:p>
             <a:r>
               <a:rPr lang="en-US" dirty="0"/>
-              <a:t>Results - Conclusions</a:t>
+              <a:t>References</a:t>
             </a:r>
           </a:p>
         </p:txBody>
@@ -4033,7 +4380,7 @@
           <p:cNvPr id="3" name="Content Placeholder 2">
             <a:extLst>
               <a:ext uri="{FF2B5EF4-FFF2-40B4-BE49-F238E27FC236}">
-                <a16:creationId xmlns:a16="http://schemas.microsoft.com/office/drawing/2014/main" id="{E4C43437-6EFE-3DBD-34CE-FF4B85FCB255}"/>
+                <a16:creationId xmlns:a16="http://schemas.microsoft.com/office/drawing/2014/main" id="{FD2F129D-B2DA-EA8B-0C9F-41CB9EA9FB72}"/>
               </a:ext>
             </a:extLst>
           </p:cNvPr>
@@ -4049,97 +4396,85 @@
           <a:bodyPr/>
           <a:lstStyle/>
           <a:p>
-            <a:endParaRPr lang="en-US"/>
+            <a:pPr marL="0" indent="0">
+              <a:buNone/>
+            </a:pPr>
+            <a:r>
+              <a:rPr lang="en-US" dirty="0"/>
+              <a:t>[1] </a:t>
+            </a:r>
+            <a:r>
+              <a:rPr lang="en-US" sz="2000" dirty="0" err="1"/>
+              <a:t>Oquab</a:t>
+            </a:r>
+            <a:r>
+              <a:rPr lang="en-US" sz="2000" dirty="0"/>
+              <a:t>, M., </a:t>
+            </a:r>
+            <a:r>
+              <a:rPr lang="en-US" sz="2000" dirty="0" err="1"/>
+              <a:t>Darcet</a:t>
+            </a:r>
+            <a:r>
+              <a:rPr lang="en-US" sz="2000" dirty="0"/>
+              <a:t>, T., </a:t>
+            </a:r>
+            <a:r>
+              <a:rPr lang="en-US" sz="2000" dirty="0" err="1"/>
+              <a:t>Moutakanni</a:t>
+            </a:r>
+            <a:r>
+              <a:rPr lang="en-US" sz="2000" dirty="0"/>
+              <a:t>, T., Vo, H., Szafraniec, M., Khalidov, V., Fernandez, P., Haziza, D., Massa, F., El-</a:t>
+            </a:r>
+            <a:r>
+              <a:rPr lang="en-US" sz="2000" dirty="0" err="1"/>
+              <a:t>Nouby</a:t>
+            </a:r>
+            <a:r>
+              <a:rPr lang="en-US" sz="2000" dirty="0"/>
+              <a:t>, A., </a:t>
+            </a:r>
+            <a:r>
+              <a:rPr lang="en-US" sz="2000" dirty="0" err="1"/>
+              <a:t>Assran</a:t>
+            </a:r>
+            <a:r>
+              <a:rPr lang="en-US" sz="2000" dirty="0"/>
+              <a:t>, M., Ballas, N., </a:t>
+            </a:r>
+            <a:r>
+              <a:rPr lang="en-US" sz="2000" dirty="0" err="1"/>
+              <a:t>Galuba</a:t>
+            </a:r>
+            <a:r>
+              <a:rPr lang="en-US" sz="2000" dirty="0"/>
+              <a:t>, W., Howes, R., Huang, P.-Y., Li, S.-W., Misra, I., Rabbat, M., Sharma, V., &amp; </a:t>
+            </a:r>
+            <a:r>
+              <a:rPr lang="en-US" sz="2000" dirty="0" err="1"/>
+              <a:t>Synnaeve</a:t>
+            </a:r>
+            <a:r>
+              <a:rPr lang="en-US" sz="2000" dirty="0"/>
+              <a:t>, G. (2023, April 14). </a:t>
+            </a:r>
+            <a:r>
+              <a:rPr lang="en-US" sz="2000" i="1" dirty="0"/>
+              <a:t>DINOv2: Learning Robust Visual Features without Supervision</a:t>
+            </a:r>
+            <a:r>
+              <a:rPr lang="en-US" sz="2000" dirty="0"/>
+              <a:t>. ArXiv.org. https://doi.org/10.48550/arXiv.2304.07193</a:t>
+            </a:r>
+            <a:endParaRPr lang="en-US" dirty="0"/>
           </a:p>
         </p:txBody>
       </p:sp>
     </p:spTree>
     <p:extLst>
       <p:ext uri="{BB962C8B-B14F-4D97-AF65-F5344CB8AC3E}">
-        <p14:creationId xmlns:p14="http://schemas.microsoft.com/office/powerpoint/2010/main" val="1850268840"/>
-      </p:ext>
-    </p:extLst>
-  </p:cSld>
-  <p:clrMapOvr>
-    <a:masterClrMapping/>
-  </p:clrMapOvr>
-</p:sld>
-</file>
-
-<file path=ppt/slides/slide9.xml><?xml version="1.0" encoding="utf-8"?>
-<p:sld xmlns:a="http://schemas.openxmlformats.org/drawingml/2006/main" xmlns:r="http://schemas.openxmlformats.org/officeDocument/2006/relationships" xmlns:p="http://schemas.openxmlformats.org/presentationml/2006/main">
-  <p:cSld>
-    <p:spTree>
-      <p:nvGrpSpPr>
-        <p:cNvPr id="1" name=""/>
-        <p:cNvGrpSpPr/>
-        <p:nvPr/>
-      </p:nvGrpSpPr>
-      <p:grpSpPr>
-        <a:xfrm>
-          <a:off x="0" y="0"/>
-          <a:ext cx="0" cy="0"/>
-          <a:chOff x="0" y="0"/>
-          <a:chExt cx="0" cy="0"/>
-        </a:xfrm>
-      </p:grpSpPr>
-      <p:sp>
-        <p:nvSpPr>
-          <p:cNvPr id="2" name="Title 1">
-            <a:extLst>
-              <a:ext uri="{FF2B5EF4-FFF2-40B4-BE49-F238E27FC236}">
-                <a16:creationId xmlns:a16="http://schemas.microsoft.com/office/drawing/2014/main" id="{6372AEE6-241C-71A9-02E0-9F442F1F9841}"/>
-              </a:ext>
-            </a:extLst>
-          </p:cNvPr>
-          <p:cNvSpPr>
-            <a:spLocks noGrp="1"/>
-          </p:cNvSpPr>
-          <p:nvPr>
-            <p:ph type="title"/>
-          </p:nvPr>
-        </p:nvSpPr>
-        <p:spPr/>
-        <p:txBody>
-          <a:bodyPr/>
-          <a:lstStyle/>
-          <a:p>
-            <a:r>
-              <a:rPr lang="en-US" dirty="0"/>
-              <a:t>Discussion</a:t>
-            </a:r>
-          </a:p>
-        </p:txBody>
-      </p:sp>
-      <p:sp>
-        <p:nvSpPr>
-          <p:cNvPr id="3" name="Content Placeholder 2">
-            <a:extLst>
-              <a:ext uri="{FF2B5EF4-FFF2-40B4-BE49-F238E27FC236}">
-                <a16:creationId xmlns:a16="http://schemas.microsoft.com/office/drawing/2014/main" id="{1B05D83F-F5EE-C965-1C13-97A22F2866AB}"/>
-              </a:ext>
-            </a:extLst>
-          </p:cNvPr>
-          <p:cNvSpPr>
-            <a:spLocks noGrp="1"/>
-          </p:cNvSpPr>
-          <p:nvPr>
-            <p:ph idx="1"/>
-          </p:nvPr>
-        </p:nvSpPr>
-        <p:spPr/>
-        <p:txBody>
-          <a:bodyPr/>
-          <a:lstStyle/>
-          <a:p>
-            <a:endParaRPr lang="en-US"/>
-          </a:p>
-        </p:txBody>
-      </p:sp>
-    </p:spTree>
-    <p:extLst>
-      <p:ext uri="{BB962C8B-B14F-4D97-AF65-F5344CB8AC3E}">
-        <p14:creationId xmlns:p14="http://schemas.microsoft.com/office/powerpoint/2010/main" val="2542129820"/>
+        <p14:creationId xmlns:p14="http://schemas.microsoft.com/office/powerpoint/2010/main" val="867442417"/>
       </p:ext>
     </p:extLst>
   </p:cSld>

</xml_diff>